<commit_message>
Slide deck: add a 'swarm in action' screenshot slide
Benjy's tweaks during the session:
- New `slide_swarm_in_action()` embeds `docs/assets/swarm_in_action.png`
  (a Run Console screenshot showing the swarm mid-run) as slide 6.
  Wired into `build_deck()` between the dashboard highlights and the
  next-steps slide.
- KPI captions expanded from "R · V · A" to the full agent names.
- The "Three-agent swarm" card now reads `avg_runtime_s` from the
  live stats instead of hard-coding ~32s.
- Next-steps long column rewritten: scale to all six countries,
  model cost-effectiveness experiments, July write-up. Column
  header is "JUNE AND JULY" rather than "TOWARDS 2 AUGUST 2026".
- Every page footer updated from n/6 to n/7 to match the new count.

`docs/PROGRESS_SLIDES_2026-05-13.pptx` regenerated to match.

Co-Authored-By: Claude Opus 4.7 <noreply@anthropic.com>
</commit_message>
<xml_diff>
--- a/docs/PROGRESS_SLIDES_2026-05-13.pptx
+++ b/docs/PROGRESS_SLIDES_2026-05-13.pptx
@@ -4,14 +4,17 @@
   <p:sldMasterIdLst>
     <p:sldMasterId id="2147483648" r:id="rId1"/>
   </p:sldMasterIdLst>
+  <p:notesMasterIdLst>
+    <p:notesMasterId r:id="rId9"/>
+  </p:notesMasterIdLst>
   <p:sldIdLst>
     <p:sldId id="256" r:id="rId2"/>
     <p:sldId id="257" r:id="rId3"/>
     <p:sldId id="258" r:id="rId4"/>
     <p:sldId id="259" r:id="rId5"/>
     <p:sldId id="260" r:id="rId6"/>
-    <p:sldId id="262" r:id="rId7"/>
-    <p:sldId id="261" r:id="rId8"/>
+    <p:sldId id="261" r:id="rId7"/>
+    <p:sldId id="262" r:id="rId8"/>
   </p:sldIdLst>
   <p:sldSz cx="9144000" cy="5143500" type="screen16x9"/>
   <p:notesSz cx="6858000" cy="9144000"/>
@@ -127,6 +130,439 @@
     </p:ext>
   </p:extLst>
 </p:presentation>
+</file>
+
+<file path=ppt/notesMasters/notesMaster1.xml><?xml version="1.0" encoding="utf-8"?>
+<p:notesMaster xmlns:a="http://schemas.openxmlformats.org/drawingml/2006/main" xmlns:r="http://schemas.openxmlformats.org/officeDocument/2006/relationships" xmlns:p="http://schemas.openxmlformats.org/presentationml/2006/main">
+  <p:cSld>
+    <p:bg>
+      <p:bgRef idx="1001">
+        <a:schemeClr val="bg1"/>
+      </p:bgRef>
+    </p:bg>
+    <p:spTree>
+      <p:nvGrpSpPr>
+        <p:cNvPr id="1" name=""/>
+        <p:cNvGrpSpPr/>
+        <p:nvPr/>
+      </p:nvGrpSpPr>
+      <p:grpSpPr>
+        <a:xfrm>
+          <a:off x="0" y="0"/>
+          <a:ext cx="0" cy="0"/>
+          <a:chOff x="0" y="0"/>
+          <a:chExt cx="0" cy="0"/>
+        </a:xfrm>
+      </p:grpSpPr>
+      <p:sp>
+        <p:nvSpPr>
+          <p:cNvPr id="2" name="Header Placeholder 1"/>
+          <p:cNvSpPr>
+            <a:spLocks noGrp="1"/>
+          </p:cNvSpPr>
+          <p:nvPr>
+            <p:ph type="hdr" sz="quarter"/>
+          </p:nvPr>
+        </p:nvSpPr>
+        <p:spPr>
+          <a:xfrm>
+            <a:off x="0" y="0"/>
+            <a:ext cx="2971800" cy="458788"/>
+          </a:xfrm>
+          <a:prstGeom prst="rect">
+            <a:avLst/>
+          </a:prstGeom>
+        </p:spPr>
+        <p:txBody>
+          <a:bodyPr vert="horz" lIns="91440" tIns="45720" rIns="91440" bIns="45720" rtlCol="0"/>
+          <a:lstStyle>
+            <a:lvl1pPr algn="l">
+              <a:defRPr sz="1200"/>
+            </a:lvl1pPr>
+          </a:lstStyle>
+          <a:p>
+            <a:endParaRPr lang="en-GB"/>
+          </a:p>
+        </p:txBody>
+      </p:sp>
+      <p:sp>
+        <p:nvSpPr>
+          <p:cNvPr id="3" name="Date Placeholder 2"/>
+          <p:cNvSpPr>
+            <a:spLocks noGrp="1"/>
+          </p:cNvSpPr>
+          <p:nvPr>
+            <p:ph type="dt" idx="1"/>
+          </p:nvPr>
+        </p:nvSpPr>
+        <p:spPr>
+          <a:xfrm>
+            <a:off x="3884613" y="0"/>
+            <a:ext cx="2971800" cy="458788"/>
+          </a:xfrm>
+          <a:prstGeom prst="rect">
+            <a:avLst/>
+          </a:prstGeom>
+        </p:spPr>
+        <p:txBody>
+          <a:bodyPr vert="horz" lIns="91440" tIns="45720" rIns="91440" bIns="45720" rtlCol="0"/>
+          <a:lstStyle>
+            <a:lvl1pPr algn="r">
+              <a:defRPr sz="1200"/>
+            </a:lvl1pPr>
+          </a:lstStyle>
+          <a:p>
+            <a:fld id="{E7A2F446-5536-9D4D-9761-025E5330F58F}" type="datetimeFigureOut">
+              <a:rPr lang="en-GB" smtClean="0"/>
+              <a:t>13/05/2026</a:t>
+            </a:fld>
+            <a:endParaRPr lang="en-GB"/>
+          </a:p>
+        </p:txBody>
+      </p:sp>
+      <p:sp>
+        <p:nvSpPr>
+          <p:cNvPr id="4" name="Slide Image Placeholder 3"/>
+          <p:cNvSpPr>
+            <a:spLocks noGrp="1" noRot="1" noChangeAspect="1"/>
+          </p:cNvSpPr>
+          <p:nvPr>
+            <p:ph type="sldImg" idx="2"/>
+          </p:nvPr>
+        </p:nvSpPr>
+        <p:spPr>
+          <a:xfrm>
+            <a:off x="685800" y="1143000"/>
+            <a:ext cx="5486400" cy="3086100"/>
+          </a:xfrm>
+          <a:prstGeom prst="rect">
+            <a:avLst/>
+          </a:prstGeom>
+          <a:noFill/>
+          <a:ln w="12700">
+            <a:solidFill>
+              <a:prstClr val="black"/>
+            </a:solidFill>
+          </a:ln>
+        </p:spPr>
+        <p:txBody>
+          <a:bodyPr vert="horz" lIns="91440" tIns="45720" rIns="91440" bIns="45720" rtlCol="0" anchor="ctr"/>
+          <a:lstStyle/>
+          <a:p>
+            <a:endParaRPr lang="en-GB"/>
+          </a:p>
+        </p:txBody>
+      </p:sp>
+      <p:sp>
+        <p:nvSpPr>
+          <p:cNvPr id="5" name="Notes Placeholder 4"/>
+          <p:cNvSpPr>
+            <a:spLocks noGrp="1"/>
+          </p:cNvSpPr>
+          <p:nvPr>
+            <p:ph type="body" sz="quarter" idx="3"/>
+          </p:nvPr>
+        </p:nvSpPr>
+        <p:spPr>
+          <a:xfrm>
+            <a:off x="685800" y="4400550"/>
+            <a:ext cx="5486400" cy="3600450"/>
+          </a:xfrm>
+          <a:prstGeom prst="rect">
+            <a:avLst/>
+          </a:prstGeom>
+        </p:spPr>
+        <p:txBody>
+          <a:bodyPr vert="horz" lIns="91440" tIns="45720" rIns="91440" bIns="45720" rtlCol="0"/>
+          <a:lstStyle/>
+          <a:p>
+            <a:pPr lvl="0"/>
+            <a:r>
+              <a:rPr lang="en-GB"/>
+              <a:t>Click to edit Master text styles</a:t>
+            </a:r>
+          </a:p>
+          <a:p>
+            <a:pPr lvl="1"/>
+            <a:r>
+              <a:rPr lang="en-GB"/>
+              <a:t>Second level</a:t>
+            </a:r>
+          </a:p>
+          <a:p>
+            <a:pPr lvl="2"/>
+            <a:r>
+              <a:rPr lang="en-GB"/>
+              <a:t>Third level</a:t>
+            </a:r>
+          </a:p>
+          <a:p>
+            <a:pPr lvl="3"/>
+            <a:r>
+              <a:rPr lang="en-GB"/>
+              <a:t>Fourth level</a:t>
+            </a:r>
+          </a:p>
+          <a:p>
+            <a:pPr lvl="4"/>
+            <a:r>
+              <a:rPr lang="en-GB"/>
+              <a:t>Fifth level</a:t>
+            </a:r>
+          </a:p>
+        </p:txBody>
+      </p:sp>
+      <p:sp>
+        <p:nvSpPr>
+          <p:cNvPr id="6" name="Footer Placeholder 5"/>
+          <p:cNvSpPr>
+            <a:spLocks noGrp="1"/>
+          </p:cNvSpPr>
+          <p:nvPr>
+            <p:ph type="ftr" sz="quarter" idx="4"/>
+          </p:nvPr>
+        </p:nvSpPr>
+        <p:spPr>
+          <a:xfrm>
+            <a:off x="0" y="8685213"/>
+            <a:ext cx="2971800" cy="458787"/>
+          </a:xfrm>
+          <a:prstGeom prst="rect">
+            <a:avLst/>
+          </a:prstGeom>
+        </p:spPr>
+        <p:txBody>
+          <a:bodyPr vert="horz" lIns="91440" tIns="45720" rIns="91440" bIns="45720" rtlCol="0" anchor="b"/>
+          <a:lstStyle>
+            <a:lvl1pPr algn="l">
+              <a:defRPr sz="1200"/>
+            </a:lvl1pPr>
+          </a:lstStyle>
+          <a:p>
+            <a:endParaRPr lang="en-GB"/>
+          </a:p>
+        </p:txBody>
+      </p:sp>
+      <p:sp>
+        <p:nvSpPr>
+          <p:cNvPr id="7" name="Slide Number Placeholder 6"/>
+          <p:cNvSpPr>
+            <a:spLocks noGrp="1"/>
+          </p:cNvSpPr>
+          <p:nvPr>
+            <p:ph type="sldNum" sz="quarter" idx="5"/>
+          </p:nvPr>
+        </p:nvSpPr>
+        <p:spPr>
+          <a:xfrm>
+            <a:off x="3884613" y="8685213"/>
+            <a:ext cx="2971800" cy="458787"/>
+          </a:xfrm>
+          <a:prstGeom prst="rect">
+            <a:avLst/>
+          </a:prstGeom>
+        </p:spPr>
+        <p:txBody>
+          <a:bodyPr vert="horz" lIns="91440" tIns="45720" rIns="91440" bIns="45720" rtlCol="0" anchor="b"/>
+          <a:lstStyle>
+            <a:lvl1pPr algn="r">
+              <a:defRPr sz="1200"/>
+            </a:lvl1pPr>
+          </a:lstStyle>
+          <a:p>
+            <a:fld id="{41B0EB74-DB58-084A-BD23-95A31DA1C717}" type="slidenum">
+              <a:rPr lang="en-GB" smtClean="0"/>
+              <a:t>‹#›</a:t>
+            </a:fld>
+            <a:endParaRPr lang="en-GB"/>
+          </a:p>
+        </p:txBody>
+      </p:sp>
+    </p:spTree>
+    <p:extLst>
+      <p:ext uri="{BB962C8B-B14F-4D97-AF65-F5344CB8AC3E}">
+        <p14:creationId xmlns:p14="http://schemas.microsoft.com/office/powerpoint/2010/main" val="2970040045"/>
+      </p:ext>
+    </p:extLst>
+  </p:cSld>
+  <p:clrMap bg1="lt1" tx1="dk1" bg2="lt2" tx2="dk2" accent1="accent1" accent2="accent2" accent3="accent3" accent4="accent4" accent5="accent5" accent6="accent6" hlink="hlink" folHlink="folHlink"/>
+  <p:notesStyle>
+    <a:lvl1pPr marL="0" algn="l" defTabSz="914400" rtl="0" eaLnBrk="1" latinLnBrk="0" hangingPunct="1">
+      <a:defRPr sz="1200" kern="1200">
+        <a:solidFill>
+          <a:schemeClr val="tx1"/>
+        </a:solidFill>
+        <a:latin typeface="+mn-lt"/>
+        <a:ea typeface="+mn-ea"/>
+        <a:cs typeface="+mn-cs"/>
+      </a:defRPr>
+    </a:lvl1pPr>
+    <a:lvl2pPr marL="457200" algn="l" defTabSz="914400" rtl="0" eaLnBrk="1" latinLnBrk="0" hangingPunct="1">
+      <a:defRPr sz="1200" kern="1200">
+        <a:solidFill>
+          <a:schemeClr val="tx1"/>
+        </a:solidFill>
+        <a:latin typeface="+mn-lt"/>
+        <a:ea typeface="+mn-ea"/>
+        <a:cs typeface="+mn-cs"/>
+      </a:defRPr>
+    </a:lvl2pPr>
+    <a:lvl3pPr marL="914400" algn="l" defTabSz="914400" rtl="0" eaLnBrk="1" latinLnBrk="0" hangingPunct="1">
+      <a:defRPr sz="1200" kern="1200">
+        <a:solidFill>
+          <a:schemeClr val="tx1"/>
+        </a:solidFill>
+        <a:latin typeface="+mn-lt"/>
+        <a:ea typeface="+mn-ea"/>
+        <a:cs typeface="+mn-cs"/>
+      </a:defRPr>
+    </a:lvl3pPr>
+    <a:lvl4pPr marL="1371600" algn="l" defTabSz="914400" rtl="0" eaLnBrk="1" latinLnBrk="0" hangingPunct="1">
+      <a:defRPr sz="1200" kern="1200">
+        <a:solidFill>
+          <a:schemeClr val="tx1"/>
+        </a:solidFill>
+        <a:latin typeface="+mn-lt"/>
+        <a:ea typeface="+mn-ea"/>
+        <a:cs typeface="+mn-cs"/>
+      </a:defRPr>
+    </a:lvl4pPr>
+    <a:lvl5pPr marL="1828800" algn="l" defTabSz="914400" rtl="0" eaLnBrk="1" latinLnBrk="0" hangingPunct="1">
+      <a:defRPr sz="1200" kern="1200">
+        <a:solidFill>
+          <a:schemeClr val="tx1"/>
+        </a:solidFill>
+        <a:latin typeface="+mn-lt"/>
+        <a:ea typeface="+mn-ea"/>
+        <a:cs typeface="+mn-cs"/>
+      </a:defRPr>
+    </a:lvl5pPr>
+    <a:lvl6pPr marL="2286000" algn="l" defTabSz="914400" rtl="0" eaLnBrk="1" latinLnBrk="0" hangingPunct="1">
+      <a:defRPr sz="1200" kern="1200">
+        <a:solidFill>
+          <a:schemeClr val="tx1"/>
+        </a:solidFill>
+        <a:latin typeface="+mn-lt"/>
+        <a:ea typeface="+mn-ea"/>
+        <a:cs typeface="+mn-cs"/>
+      </a:defRPr>
+    </a:lvl6pPr>
+    <a:lvl7pPr marL="2743200" algn="l" defTabSz="914400" rtl="0" eaLnBrk="1" latinLnBrk="0" hangingPunct="1">
+      <a:defRPr sz="1200" kern="1200">
+        <a:solidFill>
+          <a:schemeClr val="tx1"/>
+        </a:solidFill>
+        <a:latin typeface="+mn-lt"/>
+        <a:ea typeface="+mn-ea"/>
+        <a:cs typeface="+mn-cs"/>
+      </a:defRPr>
+    </a:lvl7pPr>
+    <a:lvl8pPr marL="3200400" algn="l" defTabSz="914400" rtl="0" eaLnBrk="1" latinLnBrk="0" hangingPunct="1">
+      <a:defRPr sz="1200" kern="1200">
+        <a:solidFill>
+          <a:schemeClr val="tx1"/>
+        </a:solidFill>
+        <a:latin typeface="+mn-lt"/>
+        <a:ea typeface="+mn-ea"/>
+        <a:cs typeface="+mn-cs"/>
+      </a:defRPr>
+    </a:lvl8pPr>
+    <a:lvl9pPr marL="3657600" algn="l" defTabSz="914400" rtl="0" eaLnBrk="1" latinLnBrk="0" hangingPunct="1">
+      <a:defRPr sz="1200" kern="1200">
+        <a:solidFill>
+          <a:schemeClr val="tx1"/>
+        </a:solidFill>
+        <a:latin typeface="+mn-lt"/>
+        <a:ea typeface="+mn-ea"/>
+        <a:cs typeface="+mn-cs"/>
+      </a:defRPr>
+    </a:lvl9pPr>
+  </p:notesStyle>
+</p:notesMaster>
+</file>
+
+<file path=ppt/notesSlides/notesSlide1.xml><?xml version="1.0" encoding="utf-8"?>
+<p:notes xmlns:a="http://schemas.openxmlformats.org/drawingml/2006/main" xmlns:r="http://schemas.openxmlformats.org/officeDocument/2006/relationships" xmlns:p="http://schemas.openxmlformats.org/presentationml/2006/main">
+  <p:cSld>
+    <p:spTree>
+      <p:nvGrpSpPr>
+        <p:cNvPr id="1" name=""/>
+        <p:cNvGrpSpPr/>
+        <p:nvPr/>
+      </p:nvGrpSpPr>
+      <p:grpSpPr>
+        <a:xfrm>
+          <a:off x="0" y="0"/>
+          <a:ext cx="0" cy="0"/>
+          <a:chOff x="0" y="0"/>
+          <a:chExt cx="0" cy="0"/>
+        </a:xfrm>
+      </p:grpSpPr>
+      <p:sp>
+        <p:nvSpPr>
+          <p:cNvPr id="2" name="Slide Image Placeholder 1"/>
+          <p:cNvSpPr>
+            <a:spLocks noGrp="1" noRot="1" noChangeAspect="1"/>
+          </p:cNvSpPr>
+          <p:nvPr>
+            <p:ph type="sldImg"/>
+          </p:nvPr>
+        </p:nvSpPr>
+        <p:spPr/>
+      </p:sp>
+      <p:sp>
+        <p:nvSpPr>
+          <p:cNvPr id="3" name="Notes Placeholder 2"/>
+          <p:cNvSpPr>
+            <a:spLocks noGrp="1"/>
+          </p:cNvSpPr>
+          <p:nvPr>
+            <p:ph type="body" idx="1"/>
+          </p:nvPr>
+        </p:nvSpPr>
+        <p:spPr/>
+        <p:txBody>
+          <a:bodyPr/>
+          <a:lstStyle/>
+          <a:p>
+            <a:endParaRPr lang="en-GB"/>
+          </a:p>
+        </p:txBody>
+      </p:sp>
+      <p:sp>
+        <p:nvSpPr>
+          <p:cNvPr id="4" name="Slide Number Placeholder 3"/>
+          <p:cNvSpPr>
+            <a:spLocks noGrp="1"/>
+          </p:cNvSpPr>
+          <p:nvPr>
+            <p:ph type="sldNum" sz="quarter" idx="5"/>
+          </p:nvPr>
+        </p:nvSpPr>
+        <p:spPr/>
+        <p:txBody>
+          <a:bodyPr/>
+          <a:lstStyle/>
+          <a:p>
+            <a:fld id="{41B0EB74-DB58-084A-BD23-95A31DA1C717}" type="slidenum">
+              <a:rPr lang="en-GB" smtClean="0"/>
+              <a:t>1</a:t>
+            </a:fld>
+            <a:endParaRPr lang="en-GB"/>
+          </a:p>
+        </p:txBody>
+      </p:sp>
+    </p:spTree>
+    <p:extLst>
+      <p:ext uri="{BB962C8B-B14F-4D97-AF65-F5344CB8AC3E}">
+        <p14:creationId xmlns:p14="http://schemas.microsoft.com/office/powerpoint/2010/main" val="2420086243"/>
+      </p:ext>
+    </p:extLst>
+  </p:cSld>
+  <p:clrMapOvr>
+    <a:masterClrMapping/>
+  </p:clrMapOvr>
+</p:notes>
 </file>
 
 <file path=ppt/slideLayouts/slideLayout1.xml><?xml version="1.0" encoding="utf-8"?>
@@ -3284,7 +3720,7 @@
         <p:spPr>
           <a:xfrm>
             <a:off x="914400" y="3657600"/>
-            <a:ext cx="7772400" cy="548640"/>
+            <a:ext cx="7772400" cy="215444"/>
           </a:xfrm>
           <a:prstGeom prst="rect">
             <a:avLst/>
@@ -3299,13 +3735,13 @@
           <a:p>
             <a:pPr algn="l"/>
             <a:r>
-              <a:rPr sz="1400" b="0">
+              <a:rPr sz="1400" b="0" dirty="0">
                 <a:solidFill>
                   <a:srgbClr val="CBD5E0"/>
                 </a:solidFill>
                 <a:latin typeface="Calibri"/>
               </a:rPr>
-              <a:t>Status snapshot and next steps for supervisor review</a:t>
+              <a:t>Status snapshot and next steps for review</a:t>
             </a:r>
           </a:p>
         </p:txBody>
@@ -3639,7 +4075,7 @@
                 </a:solidFill>
                 <a:latin typeface="Calibri"/>
               </a:rPr>
-              <a:t>11</a:t>
+              <a:t>44</a:t>
             </a:r>
           </a:p>
         </p:txBody>
@@ -3674,7 +4110,7 @@
                 </a:solidFill>
                 <a:latin typeface="Calibri"/>
               </a:rPr>
-              <a:t>19 R · 17 V · 2 A.</a:t>
+              <a:t>81 Researcher · 79 Verifier · 10 Adjudicator.</a:t>
             </a:r>
           </a:p>
         </p:txBody>
@@ -4029,7 +4465,7 @@
                 </a:solidFill>
                 <a:latin typeface="Calibri"/>
               </a:rPr>
-              <a:t>100%</a:t>
+              <a:t>84%</a:t>
             </a:r>
           </a:p>
         </p:txBody>
@@ -4064,7 +4500,7 @@
                 </a:solidFill>
                 <a:latin typeface="Calibri"/>
               </a:rPr>
-              <a:t>11 / 11 match against ODMI 2025.</a:t>
+              <a:t>37 / 44 match against ODMI 2025.</a:t>
             </a:r>
           </a:p>
         </p:txBody>
@@ -4203,7 +4639,7 @@
         <p:spPr>
           <a:xfrm>
             <a:off x="6954012" y="1563624"/>
-            <a:ext cx="1632204" cy="548640"/>
+            <a:ext cx="1632204" cy="338554"/>
           </a:xfrm>
           <a:prstGeom prst="rect">
             <a:avLst/>
@@ -4218,13 +4654,13 @@
           <a:p>
             <a:pPr algn="l"/>
             <a:r>
-              <a:rPr sz="2200" b="1">
+              <a:rPr sz="2200" b="1" dirty="0">
                 <a:solidFill>
                   <a:srgbClr val="1A202C"/>
                 </a:solidFill>
                 <a:latin typeface="Calibri"/>
               </a:rPr>
-              <a:t>$1.02</a:t>
+              <a:t>£4.17</a:t>
             </a:r>
           </a:p>
         </p:txBody>
@@ -4419,7 +4855,7 @@
                 </a:solidFill>
                 <a:latin typeface="Calibri"/>
               </a:rPr>
-              <a:t>Researcher proposes, Verifier tries to disprove, Adjudicator decides on retry exhaustion. One pair (P2/NL) has needed the Adjudicator. Average runtime ~32s.</a:t>
+              <a:t>Researcher proposes, Verifier tries to disprove, Adjudicator steps in when retries are exhausted. Average runtime ~106s.</a:t>
             </a:r>
           </a:p>
         </p:txBody>
@@ -4614,7 +5050,7 @@
                 </a:solidFill>
                 <a:latin typeface="Calibri"/>
               </a:rPr>
-              <a:t>ODMI Agent Swarm  ·  Benjy Bream  ·  King's College London  ·  2 / 6</a:t>
+              <a:t>ODMI Agent Swarm  ·  Benjy Bream  ·  King's College London  ·  2 / 7</a:t>
             </a:r>
           </a:p>
         </p:txBody>
@@ -5472,7 +5908,7 @@
                 </a:solidFill>
                 <a:latin typeface="Calibri"/>
               </a:rPr>
-              <a:t>ODMI Agent Swarm  ·  Benjy Bream  ·  King's College London  ·  3 / 6</a:t>
+              <a:t>ODMI Agent Swarm  ·  Benjy Bream  ·  King's College London  ·  3 / 7</a:t>
             </a:r>
           </a:p>
         </p:txBody>
@@ -5775,6 +6211,391 @@
         </p:nvSpPr>
         <p:spPr>
           <a:xfrm>
+            <a:off x="685800" y="2927350"/>
+            <a:ext cx="411480" cy="182880"/>
+          </a:xfrm>
+          <a:prstGeom prst="rect">
+            <a:avLst/>
+          </a:prstGeom>
+          <a:noFill/>
+        </p:spPr>
+        <p:txBody>
+          <a:bodyPr wrap="square" lIns="0" tIns="0" rIns="0" bIns="0">
+            <a:spAutoFit/>
+          </a:bodyPr>
+          <a:lstStyle/>
+          <a:p>
+            <a:pPr algn="r"/>
+            <a:r>
+              <a:rPr sz="900" b="0">
+                <a:solidFill>
+                  <a:srgbClr val="718096"/>
+                </a:solidFill>
+                <a:latin typeface="Calibri"/>
+              </a:rPr>
+              <a:t>1</a:t>
+            </a:r>
+          </a:p>
+        </p:txBody>
+      </p:sp>
+      <p:sp>
+        <p:nvSpPr>
+          <p:cNvPr id="10" name="TextBox 9"/>
+          <p:cNvSpPr txBox="1"/>
+          <p:nvPr/>
+        </p:nvSpPr>
+        <p:spPr>
+          <a:xfrm>
+            <a:off x="685800" y="2882900"/>
+            <a:ext cx="411480" cy="182880"/>
+          </a:xfrm>
+          <a:prstGeom prst="rect">
+            <a:avLst/>
+          </a:prstGeom>
+          <a:noFill/>
+        </p:spPr>
+        <p:txBody>
+          <a:bodyPr wrap="square" lIns="0" tIns="0" rIns="0" bIns="0">
+            <a:spAutoFit/>
+          </a:bodyPr>
+          <a:lstStyle/>
+          <a:p>
+            <a:pPr algn="r"/>
+            <a:r>
+              <a:rPr sz="900" b="0">
+                <a:solidFill>
+                  <a:srgbClr val="718096"/>
+                </a:solidFill>
+                <a:latin typeface="Calibri"/>
+              </a:rPr>
+              <a:t>2</a:t>
+            </a:r>
+          </a:p>
+        </p:txBody>
+      </p:sp>
+      <p:sp>
+        <p:nvSpPr>
+          <p:cNvPr id="11" name="TextBox 10"/>
+          <p:cNvSpPr txBox="1"/>
+          <p:nvPr/>
+        </p:nvSpPr>
+        <p:spPr>
+          <a:xfrm>
+            <a:off x="685800" y="2838450"/>
+            <a:ext cx="411480" cy="182880"/>
+          </a:xfrm>
+          <a:prstGeom prst="rect">
+            <a:avLst/>
+          </a:prstGeom>
+          <a:noFill/>
+        </p:spPr>
+        <p:txBody>
+          <a:bodyPr wrap="square" lIns="0" tIns="0" rIns="0" bIns="0">
+            <a:spAutoFit/>
+          </a:bodyPr>
+          <a:lstStyle/>
+          <a:p>
+            <a:pPr algn="r"/>
+            <a:r>
+              <a:rPr sz="900" b="0">
+                <a:solidFill>
+                  <a:srgbClr val="718096"/>
+                </a:solidFill>
+                <a:latin typeface="Calibri"/>
+              </a:rPr>
+              <a:t>3</a:t>
+            </a:r>
+          </a:p>
+        </p:txBody>
+      </p:sp>
+      <p:sp>
+        <p:nvSpPr>
+          <p:cNvPr id="12" name="TextBox 11"/>
+          <p:cNvSpPr txBox="1"/>
+          <p:nvPr/>
+        </p:nvSpPr>
+        <p:spPr>
+          <a:xfrm>
+            <a:off x="685800" y="2794000"/>
+            <a:ext cx="411480" cy="182880"/>
+          </a:xfrm>
+          <a:prstGeom prst="rect">
+            <a:avLst/>
+          </a:prstGeom>
+          <a:noFill/>
+        </p:spPr>
+        <p:txBody>
+          <a:bodyPr wrap="square" lIns="0" tIns="0" rIns="0" bIns="0">
+            <a:spAutoFit/>
+          </a:bodyPr>
+          <a:lstStyle/>
+          <a:p>
+            <a:pPr algn="r"/>
+            <a:r>
+              <a:rPr sz="900" b="0">
+                <a:solidFill>
+                  <a:srgbClr val="718096"/>
+                </a:solidFill>
+                <a:latin typeface="Calibri"/>
+              </a:rPr>
+              <a:t>4</a:t>
+            </a:r>
+          </a:p>
+        </p:txBody>
+      </p:sp>
+      <p:sp>
+        <p:nvSpPr>
+          <p:cNvPr id="13" name="TextBox 12"/>
+          <p:cNvSpPr txBox="1"/>
+          <p:nvPr/>
+        </p:nvSpPr>
+        <p:spPr>
+          <a:xfrm>
+            <a:off x="685800" y="2749550"/>
+            <a:ext cx="411480" cy="182880"/>
+          </a:xfrm>
+          <a:prstGeom prst="rect">
+            <a:avLst/>
+          </a:prstGeom>
+          <a:noFill/>
+        </p:spPr>
+        <p:txBody>
+          <a:bodyPr wrap="square" lIns="0" tIns="0" rIns="0" bIns="0">
+            <a:spAutoFit/>
+          </a:bodyPr>
+          <a:lstStyle/>
+          <a:p>
+            <a:pPr algn="r"/>
+            <a:r>
+              <a:rPr sz="900" b="0">
+                <a:solidFill>
+                  <a:srgbClr val="718096"/>
+                </a:solidFill>
+                <a:latin typeface="Calibri"/>
+              </a:rPr>
+              <a:t>5</a:t>
+            </a:r>
+          </a:p>
+        </p:txBody>
+      </p:sp>
+      <p:sp>
+        <p:nvSpPr>
+          <p:cNvPr id="14" name="TextBox 13"/>
+          <p:cNvSpPr txBox="1"/>
+          <p:nvPr/>
+        </p:nvSpPr>
+        <p:spPr>
+          <a:xfrm>
+            <a:off x="685800" y="2705100"/>
+            <a:ext cx="411480" cy="182880"/>
+          </a:xfrm>
+          <a:prstGeom prst="rect">
+            <a:avLst/>
+          </a:prstGeom>
+          <a:noFill/>
+        </p:spPr>
+        <p:txBody>
+          <a:bodyPr wrap="square" lIns="0" tIns="0" rIns="0" bIns="0">
+            <a:spAutoFit/>
+          </a:bodyPr>
+          <a:lstStyle/>
+          <a:p>
+            <a:pPr algn="r"/>
+            <a:r>
+              <a:rPr sz="900" b="0">
+                <a:solidFill>
+                  <a:srgbClr val="718096"/>
+                </a:solidFill>
+                <a:latin typeface="Calibri"/>
+              </a:rPr>
+              <a:t>6</a:t>
+            </a:r>
+          </a:p>
+        </p:txBody>
+      </p:sp>
+      <p:sp>
+        <p:nvSpPr>
+          <p:cNvPr id="15" name="TextBox 14"/>
+          <p:cNvSpPr txBox="1"/>
+          <p:nvPr/>
+        </p:nvSpPr>
+        <p:spPr>
+          <a:xfrm>
+            <a:off x="685800" y="2660650"/>
+            <a:ext cx="411480" cy="182880"/>
+          </a:xfrm>
+          <a:prstGeom prst="rect">
+            <a:avLst/>
+          </a:prstGeom>
+          <a:noFill/>
+        </p:spPr>
+        <p:txBody>
+          <a:bodyPr wrap="square" lIns="0" tIns="0" rIns="0" bIns="0">
+            <a:spAutoFit/>
+          </a:bodyPr>
+          <a:lstStyle/>
+          <a:p>
+            <a:pPr algn="r"/>
+            <a:r>
+              <a:rPr sz="900" b="0">
+                <a:solidFill>
+                  <a:srgbClr val="718096"/>
+                </a:solidFill>
+                <a:latin typeface="Calibri"/>
+              </a:rPr>
+              <a:t>7</a:t>
+            </a:r>
+          </a:p>
+        </p:txBody>
+      </p:sp>
+      <p:sp>
+        <p:nvSpPr>
+          <p:cNvPr id="16" name="TextBox 15"/>
+          <p:cNvSpPr txBox="1"/>
+          <p:nvPr/>
+        </p:nvSpPr>
+        <p:spPr>
+          <a:xfrm>
+            <a:off x="685800" y="2616200"/>
+            <a:ext cx="411480" cy="182880"/>
+          </a:xfrm>
+          <a:prstGeom prst="rect">
+            <a:avLst/>
+          </a:prstGeom>
+          <a:noFill/>
+        </p:spPr>
+        <p:txBody>
+          <a:bodyPr wrap="square" lIns="0" tIns="0" rIns="0" bIns="0">
+            <a:spAutoFit/>
+          </a:bodyPr>
+          <a:lstStyle/>
+          <a:p>
+            <a:pPr algn="r"/>
+            <a:r>
+              <a:rPr sz="900" b="0">
+                <a:solidFill>
+                  <a:srgbClr val="718096"/>
+                </a:solidFill>
+                <a:latin typeface="Calibri"/>
+              </a:rPr>
+              <a:t>8</a:t>
+            </a:r>
+          </a:p>
+        </p:txBody>
+      </p:sp>
+      <p:sp>
+        <p:nvSpPr>
+          <p:cNvPr id="17" name="TextBox 16"/>
+          <p:cNvSpPr txBox="1"/>
+          <p:nvPr/>
+        </p:nvSpPr>
+        <p:spPr>
+          <a:xfrm>
+            <a:off x="685800" y="2571750"/>
+            <a:ext cx="411480" cy="182880"/>
+          </a:xfrm>
+          <a:prstGeom prst="rect">
+            <a:avLst/>
+          </a:prstGeom>
+          <a:noFill/>
+        </p:spPr>
+        <p:txBody>
+          <a:bodyPr wrap="square" lIns="0" tIns="0" rIns="0" bIns="0">
+            <a:spAutoFit/>
+          </a:bodyPr>
+          <a:lstStyle/>
+          <a:p>
+            <a:pPr algn="r"/>
+            <a:r>
+              <a:rPr sz="900" b="0">
+                <a:solidFill>
+                  <a:srgbClr val="718096"/>
+                </a:solidFill>
+                <a:latin typeface="Calibri"/>
+              </a:rPr>
+              <a:t>9</a:t>
+            </a:r>
+          </a:p>
+        </p:txBody>
+      </p:sp>
+      <p:sp>
+        <p:nvSpPr>
+          <p:cNvPr id="18" name="TextBox 17"/>
+          <p:cNvSpPr txBox="1"/>
+          <p:nvPr/>
+        </p:nvSpPr>
+        <p:spPr>
+          <a:xfrm>
+            <a:off x="685800" y="2527300"/>
+            <a:ext cx="411480" cy="182880"/>
+          </a:xfrm>
+          <a:prstGeom prst="rect">
+            <a:avLst/>
+          </a:prstGeom>
+          <a:noFill/>
+        </p:spPr>
+        <p:txBody>
+          <a:bodyPr wrap="square" lIns="0" tIns="0" rIns="0" bIns="0">
+            <a:spAutoFit/>
+          </a:bodyPr>
+          <a:lstStyle/>
+          <a:p>
+            <a:pPr algn="r"/>
+            <a:r>
+              <a:rPr sz="900" b="0">
+                <a:solidFill>
+                  <a:srgbClr val="718096"/>
+                </a:solidFill>
+                <a:latin typeface="Calibri"/>
+              </a:rPr>
+              <a:t>10</a:t>
+            </a:r>
+          </a:p>
+        </p:txBody>
+      </p:sp>
+      <p:sp>
+        <p:nvSpPr>
+          <p:cNvPr id="19" name="TextBox 18"/>
+          <p:cNvSpPr txBox="1"/>
+          <p:nvPr/>
+        </p:nvSpPr>
+        <p:spPr>
+          <a:xfrm>
+            <a:off x="685800" y="2482850"/>
+            <a:ext cx="411480" cy="182880"/>
+          </a:xfrm>
+          <a:prstGeom prst="rect">
+            <a:avLst/>
+          </a:prstGeom>
+          <a:noFill/>
+        </p:spPr>
+        <p:txBody>
+          <a:bodyPr wrap="square" lIns="0" tIns="0" rIns="0" bIns="0">
+            <a:spAutoFit/>
+          </a:bodyPr>
+          <a:lstStyle/>
+          <a:p>
+            <a:pPr algn="r"/>
+            <a:r>
+              <a:rPr sz="900" b="0">
+                <a:solidFill>
+                  <a:srgbClr val="718096"/>
+                </a:solidFill>
+                <a:latin typeface="Calibri"/>
+              </a:rPr>
+              <a:t>11</a:t>
+            </a:r>
+          </a:p>
+        </p:txBody>
+      </p:sp>
+      <p:sp>
+        <p:nvSpPr>
+          <p:cNvPr id="20" name="TextBox 19"/>
+          <p:cNvSpPr txBox="1"/>
+          <p:nvPr/>
+        </p:nvSpPr>
+        <p:spPr>
+          <a:xfrm>
             <a:off x="685800" y="2438400"/>
             <a:ext cx="411480" cy="182880"/>
           </a:xfrm>
@@ -5797,14 +6618,399 @@
                 </a:solidFill>
                 <a:latin typeface="Calibri"/>
               </a:rPr>
-              <a:t>1</a:t>
-            </a:r>
-          </a:p>
-        </p:txBody>
-      </p:sp>
-      <p:sp>
-        <p:nvSpPr>
-          <p:cNvPr id="10" name="TextBox 9"/>
+              <a:t>12</a:t>
+            </a:r>
+          </a:p>
+        </p:txBody>
+      </p:sp>
+      <p:sp>
+        <p:nvSpPr>
+          <p:cNvPr id="21" name="TextBox 20"/>
+          <p:cNvSpPr txBox="1"/>
+          <p:nvPr/>
+        </p:nvSpPr>
+        <p:spPr>
+          <a:xfrm>
+            <a:off x="685800" y="2393950"/>
+            <a:ext cx="411480" cy="182880"/>
+          </a:xfrm>
+          <a:prstGeom prst="rect">
+            <a:avLst/>
+          </a:prstGeom>
+          <a:noFill/>
+        </p:spPr>
+        <p:txBody>
+          <a:bodyPr wrap="square" lIns="0" tIns="0" rIns="0" bIns="0">
+            <a:spAutoFit/>
+          </a:bodyPr>
+          <a:lstStyle/>
+          <a:p>
+            <a:pPr algn="r"/>
+            <a:r>
+              <a:rPr sz="900" b="0">
+                <a:solidFill>
+                  <a:srgbClr val="718096"/>
+                </a:solidFill>
+                <a:latin typeface="Calibri"/>
+              </a:rPr>
+              <a:t>13</a:t>
+            </a:r>
+          </a:p>
+        </p:txBody>
+      </p:sp>
+      <p:sp>
+        <p:nvSpPr>
+          <p:cNvPr id="22" name="TextBox 21"/>
+          <p:cNvSpPr txBox="1"/>
+          <p:nvPr/>
+        </p:nvSpPr>
+        <p:spPr>
+          <a:xfrm>
+            <a:off x="685800" y="2349500"/>
+            <a:ext cx="411480" cy="182880"/>
+          </a:xfrm>
+          <a:prstGeom prst="rect">
+            <a:avLst/>
+          </a:prstGeom>
+          <a:noFill/>
+        </p:spPr>
+        <p:txBody>
+          <a:bodyPr wrap="square" lIns="0" tIns="0" rIns="0" bIns="0">
+            <a:spAutoFit/>
+          </a:bodyPr>
+          <a:lstStyle/>
+          <a:p>
+            <a:pPr algn="r"/>
+            <a:r>
+              <a:rPr sz="900" b="0">
+                <a:solidFill>
+                  <a:srgbClr val="718096"/>
+                </a:solidFill>
+                <a:latin typeface="Calibri"/>
+              </a:rPr>
+              <a:t>14</a:t>
+            </a:r>
+          </a:p>
+        </p:txBody>
+      </p:sp>
+      <p:sp>
+        <p:nvSpPr>
+          <p:cNvPr id="23" name="TextBox 22"/>
+          <p:cNvSpPr txBox="1"/>
+          <p:nvPr/>
+        </p:nvSpPr>
+        <p:spPr>
+          <a:xfrm>
+            <a:off x="685800" y="2305050"/>
+            <a:ext cx="411480" cy="182880"/>
+          </a:xfrm>
+          <a:prstGeom prst="rect">
+            <a:avLst/>
+          </a:prstGeom>
+          <a:noFill/>
+        </p:spPr>
+        <p:txBody>
+          <a:bodyPr wrap="square" lIns="0" tIns="0" rIns="0" bIns="0">
+            <a:spAutoFit/>
+          </a:bodyPr>
+          <a:lstStyle/>
+          <a:p>
+            <a:pPr algn="r"/>
+            <a:r>
+              <a:rPr sz="900" b="0">
+                <a:solidFill>
+                  <a:srgbClr val="718096"/>
+                </a:solidFill>
+                <a:latin typeface="Calibri"/>
+              </a:rPr>
+              <a:t>15</a:t>
+            </a:r>
+          </a:p>
+        </p:txBody>
+      </p:sp>
+      <p:sp>
+        <p:nvSpPr>
+          <p:cNvPr id="24" name="TextBox 23"/>
+          <p:cNvSpPr txBox="1"/>
+          <p:nvPr/>
+        </p:nvSpPr>
+        <p:spPr>
+          <a:xfrm>
+            <a:off x="685800" y="2260600"/>
+            <a:ext cx="411480" cy="182880"/>
+          </a:xfrm>
+          <a:prstGeom prst="rect">
+            <a:avLst/>
+          </a:prstGeom>
+          <a:noFill/>
+        </p:spPr>
+        <p:txBody>
+          <a:bodyPr wrap="square" lIns="0" tIns="0" rIns="0" bIns="0">
+            <a:spAutoFit/>
+          </a:bodyPr>
+          <a:lstStyle/>
+          <a:p>
+            <a:pPr algn="r"/>
+            <a:r>
+              <a:rPr sz="900" b="0">
+                <a:solidFill>
+                  <a:srgbClr val="718096"/>
+                </a:solidFill>
+                <a:latin typeface="Calibri"/>
+              </a:rPr>
+              <a:t>16</a:t>
+            </a:r>
+          </a:p>
+        </p:txBody>
+      </p:sp>
+      <p:sp>
+        <p:nvSpPr>
+          <p:cNvPr id="25" name="TextBox 24"/>
+          <p:cNvSpPr txBox="1"/>
+          <p:nvPr/>
+        </p:nvSpPr>
+        <p:spPr>
+          <a:xfrm>
+            <a:off x="685800" y="2216150"/>
+            <a:ext cx="411480" cy="182880"/>
+          </a:xfrm>
+          <a:prstGeom prst="rect">
+            <a:avLst/>
+          </a:prstGeom>
+          <a:noFill/>
+        </p:spPr>
+        <p:txBody>
+          <a:bodyPr wrap="square" lIns="0" tIns="0" rIns="0" bIns="0">
+            <a:spAutoFit/>
+          </a:bodyPr>
+          <a:lstStyle/>
+          <a:p>
+            <a:pPr algn="r"/>
+            <a:r>
+              <a:rPr sz="900" b="0">
+                <a:solidFill>
+                  <a:srgbClr val="718096"/>
+                </a:solidFill>
+                <a:latin typeface="Calibri"/>
+              </a:rPr>
+              <a:t>17</a:t>
+            </a:r>
+          </a:p>
+        </p:txBody>
+      </p:sp>
+      <p:sp>
+        <p:nvSpPr>
+          <p:cNvPr id="26" name="TextBox 25"/>
+          <p:cNvSpPr txBox="1"/>
+          <p:nvPr/>
+        </p:nvSpPr>
+        <p:spPr>
+          <a:xfrm>
+            <a:off x="685800" y="2171700"/>
+            <a:ext cx="411480" cy="182880"/>
+          </a:xfrm>
+          <a:prstGeom prst="rect">
+            <a:avLst/>
+          </a:prstGeom>
+          <a:noFill/>
+        </p:spPr>
+        <p:txBody>
+          <a:bodyPr wrap="square" lIns="0" tIns="0" rIns="0" bIns="0">
+            <a:spAutoFit/>
+          </a:bodyPr>
+          <a:lstStyle/>
+          <a:p>
+            <a:pPr algn="r"/>
+            <a:r>
+              <a:rPr sz="900" b="0">
+                <a:solidFill>
+                  <a:srgbClr val="718096"/>
+                </a:solidFill>
+                <a:latin typeface="Calibri"/>
+              </a:rPr>
+              <a:t>18</a:t>
+            </a:r>
+          </a:p>
+        </p:txBody>
+      </p:sp>
+      <p:sp>
+        <p:nvSpPr>
+          <p:cNvPr id="27" name="TextBox 26"/>
+          <p:cNvSpPr txBox="1"/>
+          <p:nvPr/>
+        </p:nvSpPr>
+        <p:spPr>
+          <a:xfrm>
+            <a:off x="685800" y="2127250"/>
+            <a:ext cx="411480" cy="182880"/>
+          </a:xfrm>
+          <a:prstGeom prst="rect">
+            <a:avLst/>
+          </a:prstGeom>
+          <a:noFill/>
+        </p:spPr>
+        <p:txBody>
+          <a:bodyPr wrap="square" lIns="0" tIns="0" rIns="0" bIns="0">
+            <a:spAutoFit/>
+          </a:bodyPr>
+          <a:lstStyle/>
+          <a:p>
+            <a:pPr algn="r"/>
+            <a:r>
+              <a:rPr sz="900" b="0">
+                <a:solidFill>
+                  <a:srgbClr val="718096"/>
+                </a:solidFill>
+                <a:latin typeface="Calibri"/>
+              </a:rPr>
+              <a:t>19</a:t>
+            </a:r>
+          </a:p>
+        </p:txBody>
+      </p:sp>
+      <p:sp>
+        <p:nvSpPr>
+          <p:cNvPr id="28" name="TextBox 27"/>
+          <p:cNvSpPr txBox="1"/>
+          <p:nvPr/>
+        </p:nvSpPr>
+        <p:spPr>
+          <a:xfrm>
+            <a:off x="685800" y="2082800"/>
+            <a:ext cx="411480" cy="182880"/>
+          </a:xfrm>
+          <a:prstGeom prst="rect">
+            <a:avLst/>
+          </a:prstGeom>
+          <a:noFill/>
+        </p:spPr>
+        <p:txBody>
+          <a:bodyPr wrap="square" lIns="0" tIns="0" rIns="0" bIns="0">
+            <a:spAutoFit/>
+          </a:bodyPr>
+          <a:lstStyle/>
+          <a:p>
+            <a:pPr algn="r"/>
+            <a:r>
+              <a:rPr sz="900" b="0">
+                <a:solidFill>
+                  <a:srgbClr val="718096"/>
+                </a:solidFill>
+                <a:latin typeface="Calibri"/>
+              </a:rPr>
+              <a:t>20</a:t>
+            </a:r>
+          </a:p>
+        </p:txBody>
+      </p:sp>
+      <p:sp>
+        <p:nvSpPr>
+          <p:cNvPr id="29" name="TextBox 28"/>
+          <p:cNvSpPr txBox="1"/>
+          <p:nvPr/>
+        </p:nvSpPr>
+        <p:spPr>
+          <a:xfrm>
+            <a:off x="685800" y="2038350"/>
+            <a:ext cx="411480" cy="182880"/>
+          </a:xfrm>
+          <a:prstGeom prst="rect">
+            <a:avLst/>
+          </a:prstGeom>
+          <a:noFill/>
+        </p:spPr>
+        <p:txBody>
+          <a:bodyPr wrap="square" lIns="0" tIns="0" rIns="0" bIns="0">
+            <a:spAutoFit/>
+          </a:bodyPr>
+          <a:lstStyle/>
+          <a:p>
+            <a:pPr algn="r"/>
+            <a:r>
+              <a:rPr sz="900" b="0">
+                <a:solidFill>
+                  <a:srgbClr val="718096"/>
+                </a:solidFill>
+                <a:latin typeface="Calibri"/>
+              </a:rPr>
+              <a:t>21</a:t>
+            </a:r>
+          </a:p>
+        </p:txBody>
+      </p:sp>
+      <p:sp>
+        <p:nvSpPr>
+          <p:cNvPr id="30" name="TextBox 29"/>
+          <p:cNvSpPr txBox="1"/>
+          <p:nvPr/>
+        </p:nvSpPr>
+        <p:spPr>
+          <a:xfrm>
+            <a:off x="685800" y="1993900"/>
+            <a:ext cx="411480" cy="182880"/>
+          </a:xfrm>
+          <a:prstGeom prst="rect">
+            <a:avLst/>
+          </a:prstGeom>
+          <a:noFill/>
+        </p:spPr>
+        <p:txBody>
+          <a:bodyPr wrap="square" lIns="0" tIns="0" rIns="0" bIns="0">
+            <a:spAutoFit/>
+          </a:bodyPr>
+          <a:lstStyle/>
+          <a:p>
+            <a:pPr algn="r"/>
+            <a:r>
+              <a:rPr sz="900" b="0">
+                <a:solidFill>
+                  <a:srgbClr val="718096"/>
+                </a:solidFill>
+                <a:latin typeface="Calibri"/>
+              </a:rPr>
+              <a:t>22</a:t>
+            </a:r>
+          </a:p>
+        </p:txBody>
+      </p:sp>
+      <p:sp>
+        <p:nvSpPr>
+          <p:cNvPr id="31" name="TextBox 30"/>
+          <p:cNvSpPr txBox="1"/>
+          <p:nvPr/>
+        </p:nvSpPr>
+        <p:spPr>
+          <a:xfrm>
+            <a:off x="685800" y="1949451"/>
+            <a:ext cx="411480" cy="182880"/>
+          </a:xfrm>
+          <a:prstGeom prst="rect">
+            <a:avLst/>
+          </a:prstGeom>
+          <a:noFill/>
+        </p:spPr>
+        <p:txBody>
+          <a:bodyPr wrap="square" lIns="0" tIns="0" rIns="0" bIns="0">
+            <a:spAutoFit/>
+          </a:bodyPr>
+          <a:lstStyle/>
+          <a:p>
+            <a:pPr algn="r"/>
+            <a:r>
+              <a:rPr sz="900" b="0">
+                <a:solidFill>
+                  <a:srgbClr val="718096"/>
+                </a:solidFill>
+                <a:latin typeface="Calibri"/>
+              </a:rPr>
+              <a:t>23</a:t>
+            </a:r>
+          </a:p>
+        </p:txBody>
+      </p:sp>
+      <p:sp>
+        <p:nvSpPr>
+          <p:cNvPr id="32" name="TextBox 31"/>
           <p:cNvSpPr txBox="1"/>
           <p:nvPr/>
         </p:nvSpPr>
@@ -5832,14 +7038,399 @@
                 </a:solidFill>
                 <a:latin typeface="Calibri"/>
               </a:rPr>
-              <a:t>2</a:t>
-            </a:r>
-          </a:p>
-        </p:txBody>
-      </p:sp>
-      <p:sp>
-        <p:nvSpPr>
-          <p:cNvPr id="11" name="TextBox 10"/>
+              <a:t>24</a:t>
+            </a:r>
+          </a:p>
+        </p:txBody>
+      </p:sp>
+      <p:sp>
+        <p:nvSpPr>
+          <p:cNvPr id="33" name="TextBox 32"/>
+          <p:cNvSpPr txBox="1"/>
+          <p:nvPr/>
+        </p:nvSpPr>
+        <p:spPr>
+          <a:xfrm>
+            <a:off x="685800" y="1860550"/>
+            <a:ext cx="411480" cy="182880"/>
+          </a:xfrm>
+          <a:prstGeom prst="rect">
+            <a:avLst/>
+          </a:prstGeom>
+          <a:noFill/>
+        </p:spPr>
+        <p:txBody>
+          <a:bodyPr wrap="square" lIns="0" tIns="0" rIns="0" bIns="0">
+            <a:spAutoFit/>
+          </a:bodyPr>
+          <a:lstStyle/>
+          <a:p>
+            <a:pPr algn="r"/>
+            <a:r>
+              <a:rPr sz="900" b="0">
+                <a:solidFill>
+                  <a:srgbClr val="718096"/>
+                </a:solidFill>
+                <a:latin typeface="Calibri"/>
+              </a:rPr>
+              <a:t>25</a:t>
+            </a:r>
+          </a:p>
+        </p:txBody>
+      </p:sp>
+      <p:sp>
+        <p:nvSpPr>
+          <p:cNvPr id="34" name="TextBox 33"/>
+          <p:cNvSpPr txBox="1"/>
+          <p:nvPr/>
+        </p:nvSpPr>
+        <p:spPr>
+          <a:xfrm>
+            <a:off x="685800" y="1816100"/>
+            <a:ext cx="411480" cy="182880"/>
+          </a:xfrm>
+          <a:prstGeom prst="rect">
+            <a:avLst/>
+          </a:prstGeom>
+          <a:noFill/>
+        </p:spPr>
+        <p:txBody>
+          <a:bodyPr wrap="square" lIns="0" tIns="0" rIns="0" bIns="0">
+            <a:spAutoFit/>
+          </a:bodyPr>
+          <a:lstStyle/>
+          <a:p>
+            <a:pPr algn="r"/>
+            <a:r>
+              <a:rPr sz="900" b="0">
+                <a:solidFill>
+                  <a:srgbClr val="718096"/>
+                </a:solidFill>
+                <a:latin typeface="Calibri"/>
+              </a:rPr>
+              <a:t>26</a:t>
+            </a:r>
+          </a:p>
+        </p:txBody>
+      </p:sp>
+      <p:sp>
+        <p:nvSpPr>
+          <p:cNvPr id="35" name="TextBox 34"/>
+          <p:cNvSpPr txBox="1"/>
+          <p:nvPr/>
+        </p:nvSpPr>
+        <p:spPr>
+          <a:xfrm>
+            <a:off x="685800" y="1771650"/>
+            <a:ext cx="411480" cy="182880"/>
+          </a:xfrm>
+          <a:prstGeom prst="rect">
+            <a:avLst/>
+          </a:prstGeom>
+          <a:noFill/>
+        </p:spPr>
+        <p:txBody>
+          <a:bodyPr wrap="square" lIns="0" tIns="0" rIns="0" bIns="0">
+            <a:spAutoFit/>
+          </a:bodyPr>
+          <a:lstStyle/>
+          <a:p>
+            <a:pPr algn="r"/>
+            <a:r>
+              <a:rPr sz="900" b="0">
+                <a:solidFill>
+                  <a:srgbClr val="718096"/>
+                </a:solidFill>
+                <a:latin typeface="Calibri"/>
+              </a:rPr>
+              <a:t>27</a:t>
+            </a:r>
+          </a:p>
+        </p:txBody>
+      </p:sp>
+      <p:sp>
+        <p:nvSpPr>
+          <p:cNvPr id="36" name="TextBox 35"/>
+          <p:cNvSpPr txBox="1"/>
+          <p:nvPr/>
+        </p:nvSpPr>
+        <p:spPr>
+          <a:xfrm>
+            <a:off x="685800" y="1727200"/>
+            <a:ext cx="411480" cy="182880"/>
+          </a:xfrm>
+          <a:prstGeom prst="rect">
+            <a:avLst/>
+          </a:prstGeom>
+          <a:noFill/>
+        </p:spPr>
+        <p:txBody>
+          <a:bodyPr wrap="square" lIns="0" tIns="0" rIns="0" bIns="0">
+            <a:spAutoFit/>
+          </a:bodyPr>
+          <a:lstStyle/>
+          <a:p>
+            <a:pPr algn="r"/>
+            <a:r>
+              <a:rPr sz="900" b="0">
+                <a:solidFill>
+                  <a:srgbClr val="718096"/>
+                </a:solidFill>
+                <a:latin typeface="Calibri"/>
+              </a:rPr>
+              <a:t>28</a:t>
+            </a:r>
+          </a:p>
+        </p:txBody>
+      </p:sp>
+      <p:sp>
+        <p:nvSpPr>
+          <p:cNvPr id="37" name="TextBox 36"/>
+          <p:cNvSpPr txBox="1"/>
+          <p:nvPr/>
+        </p:nvSpPr>
+        <p:spPr>
+          <a:xfrm>
+            <a:off x="685800" y="1682750"/>
+            <a:ext cx="411480" cy="182880"/>
+          </a:xfrm>
+          <a:prstGeom prst="rect">
+            <a:avLst/>
+          </a:prstGeom>
+          <a:noFill/>
+        </p:spPr>
+        <p:txBody>
+          <a:bodyPr wrap="square" lIns="0" tIns="0" rIns="0" bIns="0">
+            <a:spAutoFit/>
+          </a:bodyPr>
+          <a:lstStyle/>
+          <a:p>
+            <a:pPr algn="r"/>
+            <a:r>
+              <a:rPr sz="900" b="0">
+                <a:solidFill>
+                  <a:srgbClr val="718096"/>
+                </a:solidFill>
+                <a:latin typeface="Calibri"/>
+              </a:rPr>
+              <a:t>29</a:t>
+            </a:r>
+          </a:p>
+        </p:txBody>
+      </p:sp>
+      <p:sp>
+        <p:nvSpPr>
+          <p:cNvPr id="38" name="TextBox 37"/>
+          <p:cNvSpPr txBox="1"/>
+          <p:nvPr/>
+        </p:nvSpPr>
+        <p:spPr>
+          <a:xfrm>
+            <a:off x="685800" y="1638300"/>
+            <a:ext cx="411480" cy="182880"/>
+          </a:xfrm>
+          <a:prstGeom prst="rect">
+            <a:avLst/>
+          </a:prstGeom>
+          <a:noFill/>
+        </p:spPr>
+        <p:txBody>
+          <a:bodyPr wrap="square" lIns="0" tIns="0" rIns="0" bIns="0">
+            <a:spAutoFit/>
+          </a:bodyPr>
+          <a:lstStyle/>
+          <a:p>
+            <a:pPr algn="r"/>
+            <a:r>
+              <a:rPr sz="900" b="0">
+                <a:solidFill>
+                  <a:srgbClr val="718096"/>
+                </a:solidFill>
+                <a:latin typeface="Calibri"/>
+              </a:rPr>
+              <a:t>30</a:t>
+            </a:r>
+          </a:p>
+        </p:txBody>
+      </p:sp>
+      <p:sp>
+        <p:nvSpPr>
+          <p:cNvPr id="39" name="TextBox 38"/>
+          <p:cNvSpPr txBox="1"/>
+          <p:nvPr/>
+        </p:nvSpPr>
+        <p:spPr>
+          <a:xfrm>
+            <a:off x="685800" y="1593850"/>
+            <a:ext cx="411480" cy="182880"/>
+          </a:xfrm>
+          <a:prstGeom prst="rect">
+            <a:avLst/>
+          </a:prstGeom>
+          <a:noFill/>
+        </p:spPr>
+        <p:txBody>
+          <a:bodyPr wrap="square" lIns="0" tIns="0" rIns="0" bIns="0">
+            <a:spAutoFit/>
+          </a:bodyPr>
+          <a:lstStyle/>
+          <a:p>
+            <a:pPr algn="r"/>
+            <a:r>
+              <a:rPr sz="900" b="0">
+                <a:solidFill>
+                  <a:srgbClr val="718096"/>
+                </a:solidFill>
+                <a:latin typeface="Calibri"/>
+              </a:rPr>
+              <a:t>31</a:t>
+            </a:r>
+          </a:p>
+        </p:txBody>
+      </p:sp>
+      <p:sp>
+        <p:nvSpPr>
+          <p:cNvPr id="40" name="TextBox 39"/>
+          <p:cNvSpPr txBox="1"/>
+          <p:nvPr/>
+        </p:nvSpPr>
+        <p:spPr>
+          <a:xfrm>
+            <a:off x="685800" y="1549400"/>
+            <a:ext cx="411480" cy="182880"/>
+          </a:xfrm>
+          <a:prstGeom prst="rect">
+            <a:avLst/>
+          </a:prstGeom>
+          <a:noFill/>
+        </p:spPr>
+        <p:txBody>
+          <a:bodyPr wrap="square" lIns="0" tIns="0" rIns="0" bIns="0">
+            <a:spAutoFit/>
+          </a:bodyPr>
+          <a:lstStyle/>
+          <a:p>
+            <a:pPr algn="r"/>
+            <a:r>
+              <a:rPr sz="900" b="0">
+                <a:solidFill>
+                  <a:srgbClr val="718096"/>
+                </a:solidFill>
+                <a:latin typeface="Calibri"/>
+              </a:rPr>
+              <a:t>32</a:t>
+            </a:r>
+          </a:p>
+        </p:txBody>
+      </p:sp>
+      <p:sp>
+        <p:nvSpPr>
+          <p:cNvPr id="41" name="TextBox 40"/>
+          <p:cNvSpPr txBox="1"/>
+          <p:nvPr/>
+        </p:nvSpPr>
+        <p:spPr>
+          <a:xfrm>
+            <a:off x="685800" y="1504950"/>
+            <a:ext cx="411480" cy="182880"/>
+          </a:xfrm>
+          <a:prstGeom prst="rect">
+            <a:avLst/>
+          </a:prstGeom>
+          <a:noFill/>
+        </p:spPr>
+        <p:txBody>
+          <a:bodyPr wrap="square" lIns="0" tIns="0" rIns="0" bIns="0">
+            <a:spAutoFit/>
+          </a:bodyPr>
+          <a:lstStyle/>
+          <a:p>
+            <a:pPr algn="r"/>
+            <a:r>
+              <a:rPr sz="900" b="0">
+                <a:solidFill>
+                  <a:srgbClr val="718096"/>
+                </a:solidFill>
+                <a:latin typeface="Calibri"/>
+              </a:rPr>
+              <a:t>33</a:t>
+            </a:r>
+          </a:p>
+        </p:txBody>
+      </p:sp>
+      <p:sp>
+        <p:nvSpPr>
+          <p:cNvPr id="42" name="TextBox 41"/>
+          <p:cNvSpPr txBox="1"/>
+          <p:nvPr/>
+        </p:nvSpPr>
+        <p:spPr>
+          <a:xfrm>
+            <a:off x="685800" y="1460500"/>
+            <a:ext cx="411480" cy="182880"/>
+          </a:xfrm>
+          <a:prstGeom prst="rect">
+            <a:avLst/>
+          </a:prstGeom>
+          <a:noFill/>
+        </p:spPr>
+        <p:txBody>
+          <a:bodyPr wrap="square" lIns="0" tIns="0" rIns="0" bIns="0">
+            <a:spAutoFit/>
+          </a:bodyPr>
+          <a:lstStyle/>
+          <a:p>
+            <a:pPr algn="r"/>
+            <a:r>
+              <a:rPr sz="900" b="0">
+                <a:solidFill>
+                  <a:srgbClr val="718096"/>
+                </a:solidFill>
+                <a:latin typeface="Calibri"/>
+              </a:rPr>
+              <a:t>34</a:t>
+            </a:r>
+          </a:p>
+        </p:txBody>
+      </p:sp>
+      <p:sp>
+        <p:nvSpPr>
+          <p:cNvPr id="43" name="TextBox 42"/>
+          <p:cNvSpPr txBox="1"/>
+          <p:nvPr/>
+        </p:nvSpPr>
+        <p:spPr>
+          <a:xfrm>
+            <a:off x="685800" y="1416050"/>
+            <a:ext cx="411480" cy="182880"/>
+          </a:xfrm>
+          <a:prstGeom prst="rect">
+            <a:avLst/>
+          </a:prstGeom>
+          <a:noFill/>
+        </p:spPr>
+        <p:txBody>
+          <a:bodyPr wrap="square" lIns="0" tIns="0" rIns="0" bIns="0">
+            <a:spAutoFit/>
+          </a:bodyPr>
+          <a:lstStyle/>
+          <a:p>
+            <a:pPr algn="r"/>
+            <a:r>
+              <a:rPr sz="900" b="0">
+                <a:solidFill>
+                  <a:srgbClr val="718096"/>
+                </a:solidFill>
+                <a:latin typeface="Calibri"/>
+              </a:rPr>
+              <a:t>35</a:t>
+            </a:r>
+          </a:p>
+        </p:txBody>
+      </p:sp>
+      <p:sp>
+        <p:nvSpPr>
+          <p:cNvPr id="44" name="TextBox 43"/>
           <p:cNvSpPr txBox="1"/>
           <p:nvPr/>
         </p:nvSpPr>
@@ -5867,21 +7458,21 @@
                 </a:solidFill>
                 <a:latin typeface="Calibri"/>
               </a:rPr>
-              <a:t>3</a:t>
-            </a:r>
-          </a:p>
-        </p:txBody>
-      </p:sp>
-      <p:sp>
-        <p:nvSpPr>
-          <p:cNvPr id="12" name="Rectangle 11"/>
+              <a:t>36</a:t>
+            </a:r>
+          </a:p>
+        </p:txBody>
+      </p:sp>
+      <p:sp>
+        <p:nvSpPr>
+          <p:cNvPr id="45" name="Rectangle 44"/>
           <p:cNvSpPr/>
           <p:nvPr/>
         </p:nvSpPr>
         <p:spPr>
           <a:xfrm>
-            <a:off x="1584769" y="1463040"/>
-            <a:ext cx="968121" cy="1600200"/>
+            <a:off x="1584769" y="2929890"/>
+            <a:ext cx="968121" cy="133350"/>
           </a:xfrm>
           <a:prstGeom prst="rect">
             <a:avLst/>
@@ -5918,7 +7509,7 @@
       </p:sp>
       <p:sp>
         <p:nvSpPr>
-          <p:cNvPr id="13" name="TextBox 12"/>
+          <p:cNvPr id="46" name="TextBox 45"/>
           <p:cNvSpPr txBox="1"/>
           <p:nvPr/>
         </p:nvSpPr>
@@ -5953,7 +7544,7 @@
       </p:sp>
       <p:sp>
         <p:nvSpPr>
-          <p:cNvPr id="14" name="TextBox 13"/>
+          <p:cNvPr id="47" name="TextBox 46"/>
           <p:cNvSpPr txBox="1"/>
           <p:nvPr/>
         </p:nvSpPr>
@@ -5988,14 +7579,58 @@
       </p:sp>
       <p:sp>
         <p:nvSpPr>
-          <p:cNvPr id="15" name="Rectangle 14"/>
+          <p:cNvPr id="48" name="Rectangle 47"/>
           <p:cNvSpPr/>
           <p:nvPr/>
         </p:nvSpPr>
         <p:spPr>
           <a:xfrm>
+            <a:off x="3344989" y="2752090"/>
+            <a:ext cx="968121" cy="311150"/>
+          </a:xfrm>
+          <a:prstGeom prst="rect">
+            <a:avLst/>
+          </a:prstGeom>
+          <a:solidFill>
+            <a:srgbClr val="C53030"/>
+          </a:solidFill>
+          <a:ln>
+            <a:noFill/>
+          </a:ln>
+        </p:spPr>
+        <p:style>
+          <a:lnRef idx="1">
+            <a:schemeClr val="accent1"/>
+          </a:lnRef>
+          <a:fillRef idx="3">
+            <a:schemeClr val="accent1"/>
+          </a:fillRef>
+          <a:effectRef idx="2">
+            <a:schemeClr val="accent1"/>
+          </a:effectRef>
+          <a:fontRef idx="minor">
+            <a:schemeClr val="lt1"/>
+          </a:fontRef>
+        </p:style>
+        <p:txBody>
+          <a:bodyPr rtlCol="0" anchor="ctr"/>
+          <a:lstStyle/>
+          <a:p>
+            <a:pPr algn="ctr"/>
+            <a:endParaRPr/>
+          </a:p>
+        </p:txBody>
+      </p:sp>
+      <p:sp>
+        <p:nvSpPr>
+          <p:cNvPr id="49" name="Rectangle 48"/>
+          <p:cNvSpPr/>
+          <p:nvPr/>
+        </p:nvSpPr>
+        <p:spPr>
+          <a:xfrm>
             <a:off x="3344989" y="1463040"/>
-            <a:ext cx="968121" cy="1600200"/>
+            <a:ext cx="968121" cy="1289050"/>
           </a:xfrm>
           <a:prstGeom prst="rect">
             <a:avLst/>
@@ -6032,7 +7667,7 @@
       </p:sp>
       <p:sp>
         <p:nvSpPr>
-          <p:cNvPr id="16" name="TextBox 15"/>
+          <p:cNvPr id="50" name="TextBox 49"/>
           <p:cNvSpPr txBox="1"/>
           <p:nvPr/>
         </p:nvSpPr>
@@ -6067,7 +7702,7 @@
       </p:sp>
       <p:sp>
         <p:nvSpPr>
-          <p:cNvPr id="17" name="TextBox 16"/>
+          <p:cNvPr id="51" name="TextBox 50"/>
           <p:cNvSpPr txBox="1"/>
           <p:nvPr/>
         </p:nvSpPr>
@@ -6095,21 +7730,21 @@
                 </a:solidFill>
                 <a:latin typeface="Calibri"/>
               </a:rPr>
-              <a:t>3 / 3</a:t>
-            </a:r>
-          </a:p>
-        </p:txBody>
-      </p:sp>
-      <p:sp>
-        <p:nvSpPr>
-          <p:cNvPr id="18" name="Rectangle 17"/>
+              <a:t>29 / 36</a:t>
+            </a:r>
+          </a:p>
+        </p:txBody>
+      </p:sp>
+      <p:sp>
+        <p:nvSpPr>
+          <p:cNvPr id="52" name="Rectangle 51"/>
           <p:cNvSpPr/>
           <p:nvPr/>
         </p:nvSpPr>
         <p:spPr>
           <a:xfrm>
-            <a:off x="5105209" y="1463040"/>
-            <a:ext cx="968121" cy="1600200"/>
+            <a:off x="5105209" y="2929890"/>
+            <a:ext cx="968121" cy="133350"/>
           </a:xfrm>
           <a:prstGeom prst="rect">
             <a:avLst/>
@@ -6146,7 +7781,7 @@
       </p:sp>
       <p:sp>
         <p:nvSpPr>
-          <p:cNvPr id="19" name="TextBox 18"/>
+          <p:cNvPr id="53" name="TextBox 52"/>
           <p:cNvSpPr txBox="1"/>
           <p:nvPr/>
         </p:nvSpPr>
@@ -6181,7 +7816,7 @@
       </p:sp>
       <p:sp>
         <p:nvSpPr>
-          <p:cNvPr id="20" name="TextBox 19"/>
+          <p:cNvPr id="54" name="TextBox 53"/>
           <p:cNvSpPr txBox="1"/>
           <p:nvPr/>
         </p:nvSpPr>
@@ -6216,14 +7851,14 @@
       </p:sp>
       <p:sp>
         <p:nvSpPr>
-          <p:cNvPr id="21" name="Rectangle 20"/>
+          <p:cNvPr id="55" name="Rectangle 54"/>
           <p:cNvSpPr/>
           <p:nvPr/>
         </p:nvSpPr>
         <p:spPr>
           <a:xfrm>
-            <a:off x="6865429" y="1996440"/>
-            <a:ext cx="968121" cy="1066800"/>
+            <a:off x="6865429" y="2974340"/>
+            <a:ext cx="968121" cy="88900"/>
           </a:xfrm>
           <a:prstGeom prst="rect">
             <a:avLst/>
@@ -6260,7 +7895,7 @@
       </p:sp>
       <p:sp>
         <p:nvSpPr>
-          <p:cNvPr id="22" name="TextBox 21"/>
+          <p:cNvPr id="56" name="TextBox 55"/>
           <p:cNvSpPr txBox="1"/>
           <p:nvPr/>
         </p:nvSpPr>
@@ -6295,7 +7930,7 @@
       </p:sp>
       <p:sp>
         <p:nvSpPr>
-          <p:cNvPr id="23" name="TextBox 22"/>
+          <p:cNvPr id="57" name="TextBox 56"/>
           <p:cNvSpPr txBox="1"/>
           <p:nvPr/>
         </p:nvSpPr>
@@ -6330,7 +7965,7 @@
       </p:sp>
       <p:sp>
         <p:nvSpPr>
-          <p:cNvPr id="24" name="Rectangle 23"/>
+          <p:cNvPr id="58" name="Rectangle 57"/>
           <p:cNvSpPr/>
           <p:nvPr/>
         </p:nvSpPr>
@@ -6374,7 +8009,7 @@
       </p:sp>
       <p:sp>
         <p:nvSpPr>
-          <p:cNvPr id="25" name="TextBox 24"/>
+          <p:cNvPr id="59" name="TextBox 58"/>
           <p:cNvSpPr txBox="1"/>
           <p:nvPr/>
         </p:nvSpPr>
@@ -6409,7 +8044,7 @@
       </p:sp>
       <p:sp>
         <p:nvSpPr>
-          <p:cNvPr id="26" name="Rectangle 25"/>
+          <p:cNvPr id="60" name="Rectangle 59"/>
           <p:cNvSpPr/>
           <p:nvPr/>
         </p:nvSpPr>
@@ -6453,7 +8088,7 @@
       </p:sp>
       <p:sp>
         <p:nvSpPr>
-          <p:cNvPr id="27" name="TextBox 26"/>
+          <p:cNvPr id="61" name="TextBox 60"/>
           <p:cNvSpPr txBox="1"/>
           <p:nvPr/>
         </p:nvSpPr>
@@ -6488,7 +8123,7 @@
       </p:sp>
       <p:sp>
         <p:nvSpPr>
-          <p:cNvPr id="28" name="Rectangle 27"/>
+          <p:cNvPr id="62" name="Rectangle 61"/>
           <p:cNvSpPr/>
           <p:nvPr/>
         </p:nvSpPr>
@@ -6532,7 +8167,7 @@
       </p:sp>
       <p:sp>
         <p:nvSpPr>
-          <p:cNvPr id="29" name="TextBox 28"/>
+          <p:cNvPr id="63" name="TextBox 62"/>
           <p:cNvSpPr txBox="1"/>
           <p:nvPr/>
         </p:nvSpPr>
@@ -6567,7 +8202,7 @@
       </p:sp>
       <p:sp>
         <p:nvSpPr>
-          <p:cNvPr id="30" name="TextBox 29"/>
+          <p:cNvPr id="64" name="TextBox 63"/>
           <p:cNvSpPr txBox="1"/>
           <p:nvPr/>
         </p:nvSpPr>
@@ -6595,7 +8230,7 @@
                 </a:solidFill>
                 <a:latin typeface="Calibri"/>
               </a:rPr>
-              <a:t>ODMI Agent Swarm  ·  Benjy Bream  ·  King's College London  ·  4 / 6</a:t>
+              <a:t>ODMI Agent Swarm  ·  Benjy Bream  ·  King's College London  ·  4 / 7</a:t>
             </a:r>
           </a:p>
         </p:txBody>
@@ -7617,7 +9252,7 @@
                 </a:solidFill>
                 <a:latin typeface="Calibri"/>
               </a:rPr>
-              <a:t>ODMI Agent Swarm  ·  Benjy Bream  ·  King's College London  ·  5 / 6</a:t>
+              <a:t>ODMI Agent Swarm  ·  Benjy Bream  ·  King's College London  ·  5 / 7</a:t>
             </a:r>
           </a:p>
         </p:txBody>
@@ -7649,7 +9284,7 @@
       </p:grpSpPr>
       <p:sp>
         <p:nvSpPr>
-          <p:cNvPr id="99" name="bg"/>
+          <p:cNvPr id="2" name="Rectangle 1"/>
           <p:cNvSpPr/>
           <p:nvPr/>
         </p:nvSpPr>
@@ -7668,17 +9303,32 @@
             <a:noFill/>
           </a:ln>
         </p:spPr>
-        <p:txBody>
-          <a:bodyPr/>
-          <a:lstStyle/>
-          <a:p>
+        <p:style>
+          <a:lnRef idx="1">
+            <a:schemeClr val="accent1"/>
+          </a:lnRef>
+          <a:fillRef idx="3">
+            <a:schemeClr val="accent1"/>
+          </a:fillRef>
+          <a:effectRef idx="2">
+            <a:schemeClr val="accent1"/>
+          </a:effectRef>
+          <a:fontRef idx="minor">
+            <a:schemeClr val="lt1"/>
+          </a:fontRef>
+        </p:style>
+        <p:txBody>
+          <a:bodyPr rtlCol="0" anchor="ctr"/>
+          <a:lstStyle/>
+          <a:p>
+            <a:pPr algn="ctr"/>
             <a:endParaRPr/>
           </a:p>
         </p:txBody>
       </p:sp>
       <p:sp>
         <p:nvSpPr>
-          <p:cNvPr id="100" name="TextBox 99"/>
+          <p:cNvPr id="3" name="TextBox 2"/>
           <p:cNvSpPr txBox="1"/>
           <p:nvPr/>
         </p:nvSpPr>
@@ -7693,7 +9343,7 @@
           <a:noFill/>
         </p:spPr>
         <p:txBody>
-          <a:bodyPr wrap="none">
+          <a:bodyPr wrap="square" lIns="0" tIns="0" rIns="0" bIns="0">
             <a:spAutoFit/>
           </a:bodyPr>
           <a:lstStyle/>
@@ -7713,7 +9363,7 @@
       </p:sp>
       <p:sp>
         <p:nvSpPr>
-          <p:cNvPr id="101" name="TextBox 100"/>
+          <p:cNvPr id="4" name="TextBox 3"/>
           <p:cNvSpPr txBox="1"/>
           <p:nvPr/>
         </p:nvSpPr>
@@ -7728,7 +9378,7 @@
           <a:noFill/>
         </p:spPr>
         <p:txBody>
-          <a:bodyPr wrap="none">
+          <a:bodyPr wrap="square" lIns="0" tIns="0" rIns="0" bIns="0">
             <a:spAutoFit/>
           </a:bodyPr>
           <a:lstStyle/>
@@ -7748,7 +9398,7 @@
       </p:sp>
       <p:pic>
         <p:nvPicPr>
-          <p:cNvPr id="102" name="Picture 101" descr="download.png"/>
+          <p:cNvPr id="5" name="Picture 4" descr="swarm_in_action.png"/>
           <p:cNvPicPr>
             <a:picLocks noChangeAspect="1"/>
           </p:cNvPicPr>
@@ -7762,8 +9412,8 @@
         </p:blipFill>
         <p:spPr>
           <a:xfrm>
-            <a:off x="993371" y="1007021"/>
-            <a:ext cx="6700058" cy="3907879"/>
+            <a:off x="457200" y="1051560"/>
+            <a:ext cx="8229600" cy="3794760"/>
           </a:xfrm>
           <a:prstGeom prst="rect">
             <a:avLst/>
@@ -7772,13 +9422,13 @@
       </p:pic>
       <p:sp>
         <p:nvSpPr>
-          <p:cNvPr id="103" name="TextBox 102"/>
-          <p:cNvSpPr txBox="1"/>
-          <p:nvPr/>
-        </p:nvSpPr>
-        <p:spPr>
-          <a:xfrm>
-            <a:off x="457200" y="4914900"/>
+          <p:cNvPr id="6" name="TextBox 5"/>
+          <p:cNvSpPr txBox="1"/>
+          <p:nvPr/>
+        </p:nvSpPr>
+        <p:spPr>
+          <a:xfrm>
+            <a:off x="457200" y="4850892"/>
             <a:ext cx="8229600" cy="182880"/>
           </a:xfrm>
           <a:prstGeom prst="rect">
@@ -7787,19 +9437,20 @@
           <a:noFill/>
         </p:spPr>
         <p:txBody>
-          <a:bodyPr wrap="none">
-            <a:spAutoFit/>
-          </a:bodyPr>
-          <a:lstStyle/>
-          <a:p>
-            <a:r>
-              <a:rPr sz="800">
+          <a:bodyPr wrap="square" lIns="0" tIns="0" rIns="0" bIns="0">
+            <a:spAutoFit/>
+          </a:bodyPr>
+          <a:lstStyle/>
+          <a:p>
+            <a:pPr algn="l"/>
+            <a:r>
+              <a:rPr sz="800" b="0">
                 <a:solidFill>
                   <a:srgbClr val="718096"/>
                 </a:solidFill>
                 <a:latin typeface="Calibri"/>
               </a:rPr>
-              <a:t>ODMI Agent Swarm  ·  Benjy Bream  ·  King’s College London  ·  6 / 7</a:t>
+              <a:t>ODMI Agent Swarm  ·  Benjy Bream  ·  King's College London  ·  6 / 7</a:t>
             </a:r>
           </a:p>
         </p:txBody>
@@ -8530,7 +10181,7 @@
                 </a:solidFill>
                 <a:latin typeface="Calibri"/>
               </a:rPr>
-              <a:t>TOWARDS 2 AUGUST 2026</a:t>
+              <a:t>JUNE AND JULY</a:t>
             </a:r>
           </a:p>
         </p:txBody>
@@ -8565,7 +10216,7 @@
                 </a:solidFill>
                 <a:latin typeface="Calibri"/>
               </a:rPr>
-              <a:t>Phase B saturation, six countries</a:t>
+              <a:t>Scale to all six countries</a:t>
             </a:r>
           </a:p>
         </p:txBody>
@@ -8579,7 +10230,7 @@
         <p:spPr>
           <a:xfrm>
             <a:off x="5394960" y="1993392"/>
-            <a:ext cx="3520440" cy="682752"/>
+            <a:ext cx="3520440" cy="615553"/>
           </a:xfrm>
           <a:prstGeom prst="rect">
             <a:avLst/>
@@ -8594,14 +10245,38 @@
           <a:p>
             <a:pPr algn="l"/>
             <a:r>
-              <a:rPr sz="1000" b="0">
+              <a:rPr sz="1000" b="0" dirty="0">
                 <a:solidFill>
                   <a:srgbClr val="2D3748"/>
                 </a:solidFill>
                 <a:latin typeface="Calibri"/>
               </a:rPr>
-              <a:t>FR, DE, NL, RO, HU, EE × all 143 questions. Cost–accuracy surface across the Haiku / Sonnet / Opus / tiered model mix.</a:t>
-            </a:r>
+              <a:t>Run all 143 questions across FR, DE, NL, RO, HU and EE — the full Phase B matrix.</a:t>
+            </a:r>
+            <a:endParaRPr lang="en-GB" sz="1000" b="0" dirty="0">
+              <a:solidFill>
+                <a:srgbClr val="2D3748"/>
+              </a:solidFill>
+              <a:latin typeface="Calibri"/>
+            </a:endParaRPr>
+          </a:p>
+          <a:p>
+            <a:pPr algn="l"/>
+            <a:r>
+              <a:rPr lang="en-GB" sz="1000" dirty="0">
+                <a:solidFill>
+                  <a:srgbClr val="2D3748"/>
+                </a:solidFill>
+                <a:latin typeface="Calibri"/>
+              </a:rPr>
+              <a:t>Either focus on where issues most often arise, or if spectacularly issue free across the board, push to full country list.</a:t>
+            </a:r>
+            <a:endParaRPr sz="1000" b="0" dirty="0">
+              <a:solidFill>
+                <a:srgbClr val="2D3748"/>
+              </a:solidFill>
+              <a:latin typeface="Calibri"/>
+            </a:endParaRPr>
           </a:p>
         </p:txBody>
       </p:sp>
@@ -8679,7 +10354,7 @@
                 </a:solidFill>
                 <a:latin typeface="Calibri"/>
               </a:rPr>
-              <a:t>External validity (2024 cycle)</a:t>
+              <a:t>Model cost-effectiveness experiments</a:t>
             </a:r>
           </a:p>
         </p:txBody>
@@ -8714,7 +10389,7 @@
                 </a:solidFill>
                 <a:latin typeface="Calibri"/>
               </a:rPr>
-              <a:t>Pipeline frozen, then run against the 2024 ODMI cycle as a held-out test. Delta against 2025 is itself a result.</a:t>
+              <a:t>Compare Haiku, Sonnet and Opus on accuracy and cost across the matrix. Build the cost-accuracy surface and identify the optimal strategy.</a:t>
             </a:r>
           </a:p>
         </p:txBody>
@@ -8772,7 +10447,7 @@
         <p:spPr>
           <a:xfrm>
             <a:off x="5394960" y="3688080"/>
-            <a:ext cx="3520440" cy="256032"/>
+            <a:ext cx="3520440" cy="169277"/>
           </a:xfrm>
           <a:prstGeom prst="rect">
             <a:avLst/>
@@ -8787,13 +10462,31 @@
           <a:p>
             <a:pPr algn="l"/>
             <a:r>
-              <a:rPr sz="1100" b="1">
+              <a:rPr sz="1100" b="1" dirty="0">
                 <a:solidFill>
                   <a:srgbClr val="1A202C"/>
                 </a:solidFill>
                 <a:latin typeface="Calibri"/>
               </a:rPr>
-              <a:t>Dissertation by 2 August 2026</a:t>
+              <a:t>July</a:t>
+            </a:r>
+            <a:r>
+              <a:rPr lang="en-GB" sz="1100" b="1" dirty="0">
+                <a:solidFill>
+                  <a:srgbClr val="1A202C"/>
+                </a:solidFill>
+                <a:latin typeface="Calibri"/>
+              </a:rPr>
+              <a:t>:</a:t>
+            </a:r>
+            <a:r>
+              <a:rPr sz="1100" b="1" dirty="0">
+                <a:solidFill>
+                  <a:srgbClr val="1A202C"/>
+                </a:solidFill>
+                <a:latin typeface="Calibri"/>
+              </a:rPr>
+              <a:t> dissertation write-up</a:t>
             </a:r>
           </a:p>
         </p:txBody>
@@ -8828,7 +10521,7 @@
                 </a:solidFill>
                 <a:latin typeface="Calibri"/>
               </a:rPr>
-              <a:t>Failure-mode taxonomy and accuracy–cost surface as the two primary contributions. Phase C (36 countries) as a stretch.</a:t>
+              <a:t>Analyse results, write methodology and findings chapters. Submission deadline: 2 August 2026.</a:t>
             </a:r>
           </a:p>
         </p:txBody>
@@ -8907,7 +10600,7 @@
                 </a:solidFill>
                 <a:latin typeface="Calibri"/>
               </a:rPr>
-              <a:t>ODMI Agent Swarm  ·  Benjy Bream  ·  King's College London  ·  6 / 6</a:t>
+              <a:t>ODMI Agent Swarm  ·  Benjy Bream  ·  King's College London  ·  7 / 7</a:t>
             </a:r>
           </a:p>
         </p:txBody>
@@ -9238,4 +10931,319 @@
   </a:objectDefaults>
   <a:extraClrSchemeLst/>
 </a:theme>
+</file>
+
+<file path=ppt/theme/theme2.xml><?xml version="1.0" encoding="utf-8"?>
+<a:theme xmlns:a="http://schemas.openxmlformats.org/drawingml/2006/main" name="Office Theme">
+  <a:themeElements>
+    <a:clrScheme name="Office">
+      <a:dk1>
+        <a:sysClr val="windowText" lastClr="000000"/>
+      </a:dk1>
+      <a:lt1>
+        <a:sysClr val="window" lastClr="FFFFFF"/>
+      </a:lt1>
+      <a:dk2>
+        <a:srgbClr val="0E2841"/>
+      </a:dk2>
+      <a:lt2>
+        <a:srgbClr val="E8E8E8"/>
+      </a:lt2>
+      <a:accent1>
+        <a:srgbClr val="156082"/>
+      </a:accent1>
+      <a:accent2>
+        <a:srgbClr val="E97132"/>
+      </a:accent2>
+      <a:accent3>
+        <a:srgbClr val="196B24"/>
+      </a:accent3>
+      <a:accent4>
+        <a:srgbClr val="0F9ED5"/>
+      </a:accent4>
+      <a:accent5>
+        <a:srgbClr val="A02B93"/>
+      </a:accent5>
+      <a:accent6>
+        <a:srgbClr val="4EA72E"/>
+      </a:accent6>
+      <a:hlink>
+        <a:srgbClr val="467886"/>
+      </a:hlink>
+      <a:folHlink>
+        <a:srgbClr val="96607D"/>
+      </a:folHlink>
+    </a:clrScheme>
+    <a:fontScheme name="Office">
+      <a:majorFont>
+        <a:latin typeface="Aptos Display" panose="02110004020202020204"/>
+        <a:ea typeface=""/>
+        <a:cs typeface=""/>
+        <a:font script="Jpan" typeface="游ゴシック Light"/>
+        <a:font script="Hang" typeface="맑은 고딕"/>
+        <a:font script="Hans" typeface="等线 Light"/>
+        <a:font script="Hant" typeface="新細明體"/>
+        <a:font script="Arab" typeface="Times New Roman"/>
+        <a:font script="Hebr" typeface="Times New Roman"/>
+        <a:font script="Thai" typeface="Angsana New"/>
+        <a:font script="Ethi" typeface="Nyala"/>
+        <a:font script="Beng" typeface="Vrinda"/>
+        <a:font script="Gujr" typeface="Shruti"/>
+        <a:font script="Khmr" typeface="MoolBoran"/>
+        <a:font script="Knda" typeface="Tunga"/>
+        <a:font script="Guru" typeface="Raavi"/>
+        <a:font script="Cans" typeface="Euphemia"/>
+        <a:font script="Cher" typeface="Plantagenet Cherokee"/>
+        <a:font script="Yiii" typeface="Microsoft Yi Baiti"/>
+        <a:font script="Tibt" typeface="Microsoft Himalaya"/>
+        <a:font script="Thaa" typeface="MV Boli"/>
+        <a:font script="Deva" typeface="Mangal"/>
+        <a:font script="Telu" typeface="Gautami"/>
+        <a:font script="Taml" typeface="Latha"/>
+        <a:font script="Syrc" typeface="Estrangelo Edessa"/>
+        <a:font script="Orya" typeface="Kalinga"/>
+        <a:font script="Mlym" typeface="Kartika"/>
+        <a:font script="Laoo" typeface="DokChampa"/>
+        <a:font script="Sinh" typeface="Iskoola Pota"/>
+        <a:font script="Mong" typeface="Mongolian Baiti"/>
+        <a:font script="Viet" typeface="Times New Roman"/>
+        <a:font script="Uigh" typeface="Microsoft Uighur"/>
+        <a:font script="Geor" typeface="Sylfaen"/>
+        <a:font script="Armn" typeface="Arial"/>
+        <a:font script="Bugi" typeface="Leelawadee UI"/>
+        <a:font script="Bopo" typeface="Microsoft JhengHei"/>
+        <a:font script="Java" typeface="Javanese Text"/>
+        <a:font script="Lisu" typeface="Segoe UI"/>
+        <a:font script="Mymr" typeface="Myanmar Text"/>
+        <a:font script="Nkoo" typeface="Ebrima"/>
+        <a:font script="Olck" typeface="Nirmala UI"/>
+        <a:font script="Osma" typeface="Ebrima"/>
+        <a:font script="Phag" typeface="Phagspa"/>
+        <a:font script="Syrn" typeface="Estrangelo Edessa"/>
+        <a:font script="Syrj" typeface="Estrangelo Edessa"/>
+        <a:font script="Syre" typeface="Estrangelo Edessa"/>
+        <a:font script="Sora" typeface="Nirmala UI"/>
+        <a:font script="Tale" typeface="Microsoft Tai Le"/>
+        <a:font script="Talu" typeface="Microsoft New Tai Lue"/>
+        <a:font script="Tfng" typeface="Ebrima"/>
+      </a:majorFont>
+      <a:minorFont>
+        <a:latin typeface="Aptos" panose="02110004020202020204"/>
+        <a:ea typeface=""/>
+        <a:cs typeface=""/>
+        <a:font script="Jpan" typeface="游ゴシック"/>
+        <a:font script="Hang" typeface="맑은 고딕"/>
+        <a:font script="Hans" typeface="等线"/>
+        <a:font script="Hant" typeface="新細明體"/>
+        <a:font script="Arab" typeface="Arial"/>
+        <a:font script="Hebr" typeface="Arial"/>
+        <a:font script="Thai" typeface="Cordia New"/>
+        <a:font script="Ethi" typeface="Nyala"/>
+        <a:font script="Beng" typeface="Vrinda"/>
+        <a:font script="Gujr" typeface="Shruti"/>
+        <a:font script="Khmr" typeface="DaunPenh"/>
+        <a:font script="Knda" typeface="Tunga"/>
+        <a:font script="Guru" typeface="Raavi"/>
+        <a:font script="Cans" typeface="Euphemia"/>
+        <a:font script="Cher" typeface="Plantagenet Cherokee"/>
+        <a:font script="Yiii" typeface="Microsoft Yi Baiti"/>
+        <a:font script="Tibt" typeface="Microsoft Himalaya"/>
+        <a:font script="Thaa" typeface="MV Boli"/>
+        <a:font script="Deva" typeface="Mangal"/>
+        <a:font script="Telu" typeface="Gautami"/>
+        <a:font script="Taml" typeface="Latha"/>
+        <a:font script="Syrc" typeface="Estrangelo Edessa"/>
+        <a:font script="Orya" typeface="Kalinga"/>
+        <a:font script="Mlym" typeface="Kartika"/>
+        <a:font script="Laoo" typeface="DokChampa"/>
+        <a:font script="Sinh" typeface="Iskoola Pota"/>
+        <a:font script="Mong" typeface="Mongolian Baiti"/>
+        <a:font script="Viet" typeface="Arial"/>
+        <a:font script="Uigh" typeface="Microsoft Uighur"/>
+        <a:font script="Geor" typeface="Sylfaen"/>
+        <a:font script="Armn" typeface="Arial"/>
+        <a:font script="Bugi" typeface="Leelawadee UI"/>
+        <a:font script="Bopo" typeface="Microsoft JhengHei"/>
+        <a:font script="Java" typeface="Javanese Text"/>
+        <a:font script="Lisu" typeface="Segoe UI"/>
+        <a:font script="Mymr" typeface="Myanmar Text"/>
+        <a:font script="Nkoo" typeface="Ebrima"/>
+        <a:font script="Olck" typeface="Nirmala UI"/>
+        <a:font script="Osma" typeface="Ebrima"/>
+        <a:font script="Phag" typeface="Phagspa"/>
+        <a:font script="Syrn" typeface="Estrangelo Edessa"/>
+        <a:font script="Syrj" typeface="Estrangelo Edessa"/>
+        <a:font script="Syre" typeface="Estrangelo Edessa"/>
+        <a:font script="Sora" typeface="Nirmala UI"/>
+        <a:font script="Tale" typeface="Microsoft Tai Le"/>
+        <a:font script="Talu" typeface="Microsoft New Tai Lue"/>
+        <a:font script="Tfng" typeface="Ebrima"/>
+      </a:minorFont>
+    </a:fontScheme>
+    <a:fmtScheme name="Office">
+      <a:fillStyleLst>
+        <a:solidFill>
+          <a:schemeClr val="phClr"/>
+        </a:solidFill>
+        <a:gradFill rotWithShape="1">
+          <a:gsLst>
+            <a:gs pos="0">
+              <a:schemeClr val="phClr">
+                <a:lumMod val="110000"/>
+                <a:satMod val="105000"/>
+                <a:tint val="67000"/>
+              </a:schemeClr>
+            </a:gs>
+            <a:gs pos="50000">
+              <a:schemeClr val="phClr">
+                <a:lumMod val="105000"/>
+                <a:satMod val="103000"/>
+                <a:tint val="73000"/>
+              </a:schemeClr>
+            </a:gs>
+            <a:gs pos="100000">
+              <a:schemeClr val="phClr">
+                <a:lumMod val="105000"/>
+                <a:satMod val="109000"/>
+                <a:tint val="81000"/>
+              </a:schemeClr>
+            </a:gs>
+          </a:gsLst>
+          <a:lin ang="5400000" scaled="0"/>
+        </a:gradFill>
+        <a:gradFill rotWithShape="1">
+          <a:gsLst>
+            <a:gs pos="0">
+              <a:schemeClr val="phClr">
+                <a:satMod val="103000"/>
+                <a:lumMod val="102000"/>
+                <a:tint val="94000"/>
+              </a:schemeClr>
+            </a:gs>
+            <a:gs pos="50000">
+              <a:schemeClr val="phClr">
+                <a:satMod val="110000"/>
+                <a:lumMod val="100000"/>
+                <a:shade val="100000"/>
+              </a:schemeClr>
+            </a:gs>
+            <a:gs pos="100000">
+              <a:schemeClr val="phClr">
+                <a:lumMod val="99000"/>
+                <a:satMod val="120000"/>
+                <a:shade val="78000"/>
+              </a:schemeClr>
+            </a:gs>
+          </a:gsLst>
+          <a:lin ang="5400000" scaled="0"/>
+        </a:gradFill>
+      </a:fillStyleLst>
+      <a:lnStyleLst>
+        <a:ln w="12700" cap="flat" cmpd="sng" algn="ctr">
+          <a:solidFill>
+            <a:schemeClr val="phClr"/>
+          </a:solidFill>
+          <a:prstDash val="solid"/>
+          <a:miter lim="800000"/>
+        </a:ln>
+        <a:ln w="19050" cap="flat" cmpd="sng" algn="ctr">
+          <a:solidFill>
+            <a:schemeClr val="phClr"/>
+          </a:solidFill>
+          <a:prstDash val="solid"/>
+          <a:miter lim="800000"/>
+        </a:ln>
+        <a:ln w="25400" cap="flat" cmpd="sng" algn="ctr">
+          <a:solidFill>
+            <a:schemeClr val="phClr"/>
+          </a:solidFill>
+          <a:prstDash val="solid"/>
+          <a:miter lim="800000"/>
+        </a:ln>
+      </a:lnStyleLst>
+      <a:effectStyleLst>
+        <a:effectStyle>
+          <a:effectLst/>
+        </a:effectStyle>
+        <a:effectStyle>
+          <a:effectLst/>
+        </a:effectStyle>
+        <a:effectStyle>
+          <a:effectLst>
+            <a:outerShdw blurRad="57150" dist="19050" dir="5400000" algn="ctr" rotWithShape="0">
+              <a:srgbClr val="000000">
+                <a:alpha val="63000"/>
+              </a:srgbClr>
+            </a:outerShdw>
+          </a:effectLst>
+        </a:effectStyle>
+      </a:effectStyleLst>
+      <a:bgFillStyleLst>
+        <a:solidFill>
+          <a:schemeClr val="phClr"/>
+        </a:solidFill>
+        <a:solidFill>
+          <a:schemeClr val="phClr">
+            <a:tint val="95000"/>
+            <a:satMod val="170000"/>
+          </a:schemeClr>
+        </a:solidFill>
+        <a:gradFill rotWithShape="1">
+          <a:gsLst>
+            <a:gs pos="0">
+              <a:schemeClr val="phClr">
+                <a:tint val="93000"/>
+                <a:satMod val="150000"/>
+                <a:shade val="98000"/>
+                <a:lumMod val="102000"/>
+              </a:schemeClr>
+            </a:gs>
+            <a:gs pos="50000">
+              <a:schemeClr val="phClr">
+                <a:tint val="98000"/>
+                <a:satMod val="130000"/>
+                <a:shade val="90000"/>
+                <a:lumMod val="103000"/>
+              </a:schemeClr>
+            </a:gs>
+            <a:gs pos="100000">
+              <a:schemeClr val="phClr">
+                <a:shade val="63000"/>
+                <a:satMod val="120000"/>
+              </a:schemeClr>
+            </a:gs>
+          </a:gsLst>
+          <a:lin ang="5400000" scaled="0"/>
+        </a:gradFill>
+      </a:bgFillStyleLst>
+    </a:fmtScheme>
+  </a:themeElements>
+  <a:objectDefaults>
+    <a:lnDef>
+      <a:spPr/>
+      <a:bodyPr/>
+      <a:lstStyle/>
+      <a:style>
+        <a:lnRef idx="2">
+          <a:schemeClr val="accent1"/>
+        </a:lnRef>
+        <a:fillRef idx="0">
+          <a:schemeClr val="accent1"/>
+        </a:fillRef>
+        <a:effectRef idx="1">
+          <a:schemeClr val="accent1"/>
+        </a:effectRef>
+        <a:fontRef idx="minor">
+          <a:schemeClr val="tx1"/>
+        </a:fontRef>
+      </a:style>
+    </a:lnDef>
+  </a:objectDefaults>
+  <a:extraClrSchemeLst/>
+  <a:extLst>
+    <a:ext uri="{05A4C25C-085E-4340-85A3-A5531E510DB2}">
+      <thm15:themeFamily xmlns:thm15="http://schemas.microsoft.com/office/thememl/2012/main" name="Office Theme" id="{2E142A2C-CD16-42D6-873A-C26D2A0506FA}" vid="{1BDDFF52-6CD6-40A5-AB3C-68EB2F1E4D0A}"/>
+    </a:ext>
+  </a:extLst>
+</a:theme>
 </file>
</xml_diff>